<commit_message>
Add Module 5: Machine Learning in Predictive Modeling
Combines Pandas and ML content into a six-part workshop:
- Part 1: Pandas Basics, Data Exploration, Data Preprocessing
- Part 2: AI-Assisted Coding, EDA & Visualization, Building ML Models

Each page links to the corresponding Google Colab notebook.
Overview shows both slide decks and a two-part card grid.

Co-authored-by: Cursor <cursoragent@cursor.com>
</commit_message>
<xml_diff>
--- a/module2/module2_gale_shapley.pptx
+++ b/module2/module2_gale_shapley.pptx
@@ -249,7 +249,7 @@
           <a:p>
             <a:fld id="{37FF37F7-B3BD-2042-A60F-5965D11BCC5D}" type="datetimeFigureOut">
               <a:rPr lang="en-US" smtClean="0"/>
-              <a:t>6/20/26</a:t>
+              <a:t>7/4/26</a:t>
             </a:fld>
             <a:endParaRPr lang="en-US"/>
           </a:p>
@@ -1164,7 +1164,7 @@
           <a:p>
             <a:fld id="{1D8BD707-D9CF-40AE-B4C6-C98DA3205C09}" type="datetimeFigureOut">
               <a:rPr lang="en-US"/>
-              <a:t>6/20/26</a:t>
+              <a:t>7/4/26</a:t>
             </a:fld>
             <a:endParaRPr lang="en-US"/>
           </a:p>
@@ -1339,7 +1339,7 @@
           <a:p>
             <a:fld id="{1D8BD707-D9CF-40AE-B4C6-C98DA3205C09}" type="datetimeFigureOut">
               <a:rPr lang="en-US"/>
-              <a:t>6/20/26</a:t>
+              <a:t>7/4/26</a:t>
             </a:fld>
             <a:endParaRPr lang="en-US"/>
           </a:p>
@@ -1477,7 +1477,7 @@
           <a:p>
             <a:fld id="{1D8BD707-D9CF-40AE-B4C6-C98DA3205C09}" type="datetimeFigureOut">
               <a:rPr lang="en-US"/>
-              <a:t>6/20/26</a:t>
+              <a:t>7/4/26</a:t>
             </a:fld>
             <a:endParaRPr lang="en-US"/>
           </a:p>
@@ -1699,7 +1699,7 @@
           <a:p>
             <a:fld id="{1D8BD707-D9CF-40AE-B4C6-C98DA3205C09}" type="datetimeFigureOut">
               <a:rPr lang="en-US"/>
-              <a:t>6/20/26</a:t>
+              <a:t>7/4/26</a:t>
             </a:fld>
             <a:endParaRPr lang="en-US"/>
           </a:p>
@@ -1837,7 +1837,7 @@
           <a:p>
             <a:fld id="{1D8BD707-D9CF-40AE-B4C6-C98DA3205C09}" type="datetimeFigureOut">
               <a:rPr lang="en-US"/>
-              <a:t>6/20/26</a:t>
+              <a:t>7/4/26</a:t>
             </a:fld>
             <a:endParaRPr lang="en-US"/>
           </a:p>
@@ -2437,7 +2437,7 @@
           <a:p>
             <a:fld id="{1D8BD707-D9CF-40AE-B4C6-C98DA3205C09}" type="datetimeFigureOut">
               <a:rPr lang="en-US"/>
-              <a:t>6/20/26</a:t>
+              <a:t>7/4/26</a:t>
             </a:fld>
             <a:endParaRPr lang="en-US"/>
           </a:p>
@@ -2684,7 +2684,7 @@
           <a:p>
             <a:fld id="{1D8BD707-D9CF-40AE-B4C6-C98DA3205C09}" type="datetimeFigureOut">
               <a:rPr lang="en-US"/>
-              <a:t>6/20/26</a:t>
+              <a:t>7/4/26</a:t>
             </a:fld>
             <a:endParaRPr lang="en-US"/>
           </a:p>
@@ -2850,7 +2850,7 @@
           <a:p>
             <a:fld id="{1D8BD707-D9CF-40AE-B4C6-C98DA3205C09}" type="datetimeFigureOut">
               <a:rPr lang="en-US"/>
-              <a:t>6/20/26</a:t>
+              <a:t>7/4/26</a:t>
             </a:fld>
             <a:endParaRPr lang="en-US"/>
           </a:p>
@@ -18653,7 +18653,7 @@
         <p:spPr>
           <a:xfrm>
             <a:off x="1066800" y="1821868"/>
-            <a:ext cx="7696200" cy="3606885"/>
+            <a:ext cx="7696200" cy="4344779"/>
           </a:xfrm>
           <a:prstGeom prst="rect">
             <a:avLst/>
@@ -18693,13 +18693,71 @@
             </a:pPr>
             <a:r>
               <a:rPr lang="en-US" sz="2400" dirty="0" err="1">
-                <a:latin typeface="Arial"/>
+                <a:solidFill>
+                  <a:srgbClr val="409081"/>
+                </a:solidFill>
+                <a:latin typeface="+mn-ea"/>
                 <a:cs typeface="Arial"/>
               </a:rPr>
               <a:t>住院医师规范化培训招录</a:t>
             </a:r>
+            <a:endParaRPr lang="en-US" sz="2400" dirty="0">
+              <a:solidFill>
+                <a:srgbClr val="409081"/>
+              </a:solidFill>
+              <a:latin typeface="+mn-ea"/>
+              <a:cs typeface="Arial"/>
+            </a:endParaRPr>
+          </a:p>
+          <a:p>
+            <a:pPr marL="12700">
+              <a:lnSpc>
+                <a:spcPct val="100000"/>
+              </a:lnSpc>
+              <a:tabLst>
+                <a:tab pos="1574800" algn="l"/>
+                <a:tab pos="2588895" algn="l"/>
+                <a:tab pos="3959225" algn="l"/>
+                <a:tab pos="4871720" algn="l"/>
+                <a:tab pos="5937250" algn="l"/>
+              </a:tabLst>
+            </a:pPr>
+            <a:endParaRPr lang="en-US" sz="2400" dirty="0">
+              <a:solidFill>
+                <a:srgbClr val="409081"/>
+              </a:solidFill>
+              <a:latin typeface="+mn-ea"/>
+              <a:cs typeface="Arial"/>
+            </a:endParaRPr>
+          </a:p>
+          <a:p>
+            <a:pPr marL="12700">
+              <a:lnSpc>
+                <a:spcPct val="100000"/>
+              </a:lnSpc>
+              <a:tabLst>
+                <a:tab pos="1574800" algn="l"/>
+                <a:tab pos="2588895" algn="l"/>
+                <a:tab pos="3959225" algn="l"/>
+                <a:tab pos="4871720" algn="l"/>
+                <a:tab pos="5937250" algn="l"/>
+              </a:tabLst>
+            </a:pPr>
+            <a:r>
+              <a:rPr lang="en-US" sz="2400" dirty="0" err="1">
+                <a:solidFill>
+                  <a:srgbClr val="409081"/>
+                </a:solidFill>
+                <a:latin typeface="+mn-ea"/>
+                <a:cs typeface="Arial"/>
+              </a:rPr>
+              <a:t>器官捐赠移植排序</a:t>
+            </a:r>
             <a:endParaRPr sz="2400" dirty="0">
-              <a:latin typeface="Arial"/>
+              <a:solidFill>
+                <a:srgbClr val="409081"/>
+              </a:solidFill>
+              <a:latin typeface="+mn-ea"/>
               <a:cs typeface="Arial"/>
             </a:endParaRPr>
           </a:p>
@@ -18712,18 +18770,18 @@
             <a:r>
               <a:rPr lang="en-US" sz="2400" spc="-5" dirty="0" err="1">
                 <a:solidFill>
-                  <a:srgbClr val="3369E8"/>
-                </a:solidFill>
-                <a:latin typeface="Arial"/>
+                  <a:srgbClr val="409081"/>
+                </a:solidFill>
+                <a:latin typeface="+mn-ea"/>
                 <a:cs typeface="Arial"/>
               </a:rPr>
               <a:t>研究生与导师的双向选择</a:t>
             </a:r>
             <a:endParaRPr lang="en-US" sz="2400" spc="-5" dirty="0">
               <a:solidFill>
-                <a:srgbClr val="3369E8"/>
+                <a:srgbClr val="409081"/>
               </a:solidFill>
-              <a:latin typeface="Arial"/>
+              <a:latin typeface="+mn-ea"/>
               <a:cs typeface="Arial"/>
             </a:endParaRPr>
           </a:p>
@@ -18736,18 +18794,18 @@
             <a:r>
               <a:rPr lang="en-US" sz="2400" spc="-5" dirty="0" err="1">
                 <a:solidFill>
-                  <a:srgbClr val="3369E8"/>
-                </a:solidFill>
-                <a:latin typeface="Arial"/>
+                  <a:srgbClr val="409081"/>
+                </a:solidFill>
+                <a:latin typeface="+mn-ea"/>
                 <a:cs typeface="Arial"/>
               </a:rPr>
               <a:t>新高考改革下的部分大类专业分流</a:t>
             </a:r>
             <a:endParaRPr lang="en-US" sz="2400" spc="-5" dirty="0">
               <a:solidFill>
-                <a:srgbClr val="3369E8"/>
+                <a:srgbClr val="409081"/>
               </a:solidFill>
-              <a:latin typeface="Arial"/>
+              <a:latin typeface="+mn-ea"/>
               <a:cs typeface="Arial"/>
             </a:endParaRPr>
           </a:p>
@@ -18760,18 +18818,18 @@
             <a:r>
               <a:rPr lang="en-US" sz="2400" spc="-5" dirty="0" err="1">
                 <a:solidFill>
-                  <a:srgbClr val="231F20"/>
-                </a:solidFill>
-                <a:latin typeface="Arial"/>
+                  <a:srgbClr val="409081"/>
+                </a:solidFill>
+                <a:latin typeface="+mn-ea"/>
                 <a:cs typeface="Arial"/>
               </a:rPr>
               <a:t>企事业单位内部人岗匹配</a:t>
             </a:r>
             <a:endParaRPr lang="en-US" sz="2400" spc="-5" dirty="0">
               <a:solidFill>
-                <a:srgbClr val="231F20"/>
+                <a:srgbClr val="409081"/>
               </a:solidFill>
-              <a:latin typeface="Arial"/>
+              <a:latin typeface="+mn-ea"/>
               <a:cs typeface="Arial"/>
             </a:endParaRPr>
           </a:p>
@@ -18784,9 +18842,9 @@
             <a:r>
               <a:rPr lang="en-US" sz="2400" spc="-5" dirty="0" err="1">
                 <a:solidFill>
-                  <a:srgbClr val="231F20"/>
-                </a:solidFill>
-                <a:latin typeface="Arial"/>
+                  <a:srgbClr val="409081"/>
+                </a:solidFill>
+                <a:latin typeface="+mn-ea"/>
                 <a:cs typeface="Arial"/>
               </a:rPr>
               <a:t>校企合作</a:t>
@@ -18794,18 +18852,18 @@
             <a:r>
               <a:rPr lang="zh-CN" altLang="en-US" sz="2400" spc="-5" dirty="0">
                 <a:solidFill>
-                  <a:srgbClr val="231F20"/>
-                </a:solidFill>
-                <a:latin typeface="Arial"/>
+                  <a:srgbClr val="409081"/>
+                </a:solidFill>
+                <a:latin typeface="+mn-ea"/>
                 <a:cs typeface="Arial"/>
               </a:rPr>
               <a:t>“订单班”与实习分配</a:t>
             </a:r>
             <a:endParaRPr lang="en-US" sz="2400" spc="-5" dirty="0">
               <a:solidFill>
-                <a:srgbClr val="231F20"/>
+                <a:srgbClr val="409081"/>
               </a:solidFill>
-              <a:latin typeface="Arial"/>
+              <a:latin typeface="+mn-ea"/>
               <a:cs typeface="Arial"/>
             </a:endParaRPr>
           </a:p>

</xml_diff>

<commit_message>
Fix practice_project3_starter.py: use ... placeholders, fix syntax errors and mismatches
Co-authored-by: Cursor <cursoragent@cursor.com>
</commit_message>
<xml_diff>
--- a/module2/module2_gale_shapley.pptx
+++ b/module2/module2_gale_shapley.pptx
@@ -249,7 +249,7 @@
           <a:p>
             <a:fld id="{37FF37F7-B3BD-2042-A60F-5965D11BCC5D}" type="datetimeFigureOut">
               <a:rPr lang="en-US" smtClean="0"/>
-              <a:t>7/4/26</a:t>
+              <a:t>7/5/26</a:t>
             </a:fld>
             <a:endParaRPr lang="en-US"/>
           </a:p>
@@ -1164,7 +1164,7 @@
           <a:p>
             <a:fld id="{1D8BD707-D9CF-40AE-B4C6-C98DA3205C09}" type="datetimeFigureOut">
               <a:rPr lang="en-US"/>
-              <a:t>7/4/26</a:t>
+              <a:t>7/5/26</a:t>
             </a:fld>
             <a:endParaRPr lang="en-US"/>
           </a:p>
@@ -1339,7 +1339,7 @@
           <a:p>
             <a:fld id="{1D8BD707-D9CF-40AE-B4C6-C98DA3205C09}" type="datetimeFigureOut">
               <a:rPr lang="en-US"/>
-              <a:t>7/4/26</a:t>
+              <a:t>7/5/26</a:t>
             </a:fld>
             <a:endParaRPr lang="en-US"/>
           </a:p>
@@ -1477,7 +1477,7 @@
           <a:p>
             <a:fld id="{1D8BD707-D9CF-40AE-B4C6-C98DA3205C09}" type="datetimeFigureOut">
               <a:rPr lang="en-US"/>
-              <a:t>7/4/26</a:t>
+              <a:t>7/5/26</a:t>
             </a:fld>
             <a:endParaRPr lang="en-US"/>
           </a:p>
@@ -1699,7 +1699,7 @@
           <a:p>
             <a:fld id="{1D8BD707-D9CF-40AE-B4C6-C98DA3205C09}" type="datetimeFigureOut">
               <a:rPr lang="en-US"/>
-              <a:t>7/4/26</a:t>
+              <a:t>7/5/26</a:t>
             </a:fld>
             <a:endParaRPr lang="en-US"/>
           </a:p>
@@ -1837,7 +1837,7 @@
           <a:p>
             <a:fld id="{1D8BD707-D9CF-40AE-B4C6-C98DA3205C09}" type="datetimeFigureOut">
               <a:rPr lang="en-US"/>
-              <a:t>7/4/26</a:t>
+              <a:t>7/5/26</a:t>
             </a:fld>
             <a:endParaRPr lang="en-US"/>
           </a:p>
@@ -2437,7 +2437,7 @@
           <a:p>
             <a:fld id="{1D8BD707-D9CF-40AE-B4C6-C98DA3205C09}" type="datetimeFigureOut">
               <a:rPr lang="en-US"/>
-              <a:t>7/4/26</a:t>
+              <a:t>7/5/26</a:t>
             </a:fld>
             <a:endParaRPr lang="en-US"/>
           </a:p>
@@ -2684,7 +2684,7 @@
           <a:p>
             <a:fld id="{1D8BD707-D9CF-40AE-B4C6-C98DA3205C09}" type="datetimeFigureOut">
               <a:rPr lang="en-US"/>
-              <a:t>7/4/26</a:t>
+              <a:t>7/5/26</a:t>
             </a:fld>
             <a:endParaRPr lang="en-US"/>
           </a:p>
@@ -2850,7 +2850,7 @@
           <a:p>
             <a:fld id="{1D8BD707-D9CF-40AE-B4C6-C98DA3205C09}" type="datetimeFigureOut">
               <a:rPr lang="en-US"/>
-              <a:t>7/4/26</a:t>
+              <a:t>7/5/26</a:t>
             </a:fld>
             <a:endParaRPr lang="en-US"/>
           </a:p>

</xml_diff>